<commit_message>
Add decision-guide and real-world-lesson slides to session deck
Incorporates reviewer feedback (missing decision guidance + missing
production war story). New slide 22 'When to Use What' maps six common
situations to the right retrieval stack, from dense-only through
hybrid+reranker to 'use SQL, not RAG'. New slide 24 'A Real-World
Lesson — When Dense Alone Fails' grounds the hybrid value prop in a
concrete ORA-04031 support-docs scenario the speaker can narrate live.
Deck grows 30 → 32 slides with footer page numbers re-synced.
</commit_message>
<xml_diff>
--- a/docs/DataHour_HybridRAG_With_ReRanker.pptx
+++ b/docs/DataHour_HybridRAG_With_ReRanker.pptx
@@ -26,7 +26,9 @@
     <p:sldId id="276" r:id="rId20"/>
     <p:sldId id="277" r:id="rId21"/>
     <p:sldId id="278" r:id="rId22"/>
+    <p:sldId id="290" r:id="rId36"/>
     <p:sldId id="279" r:id="rId23"/>
+    <p:sldId id="291" r:id="rId37"/>
     <p:sldId id="280" r:id="rId24"/>
     <p:sldId id="281" r:id="rId25"/>
     <p:sldId id="282" r:id="rId26"/>
@@ -13387,7 +13389,7 @@
                   <a:srgbClr val="AAAAAA"/>
                 </a:solidFill>
               </a:rPr>
-              <a:t>22</a:t>
+              <a:t>23</a:t>
             </a:r>
           </a:p>
         </p:txBody>
@@ -13885,7 +13887,7 @@
                   <a:srgbClr val="AAAAAA"/>
                 </a:solidFill>
               </a:rPr>
-              <a:t>23</a:t>
+              <a:t>25</a:t>
             </a:r>
           </a:p>
         </p:txBody>
@@ -14358,7 +14360,7 @@
                   <a:srgbClr val="AAAAAA"/>
                 </a:solidFill>
               </a:rPr>
-              <a:t>24</a:t>
+              <a:t>26</a:t>
             </a:r>
           </a:p>
         </p:txBody>
@@ -14831,7 +14833,7 @@
                   <a:srgbClr val="AAAAAA"/>
                 </a:solidFill>
               </a:rPr>
-              <a:t>25</a:t>
+              <a:t>27</a:t>
             </a:r>
           </a:p>
         </p:txBody>
@@ -15353,7 +15355,7 @@
                   <a:srgbClr val="AAAAAA"/>
                 </a:solidFill>
               </a:rPr>
-              <a:t>26</a:t>
+              <a:t>28</a:t>
             </a:r>
           </a:p>
         </p:txBody>
@@ -15625,7 +15627,7 @@
                   <a:srgbClr val="AAAAAA"/>
                 </a:solidFill>
               </a:rPr>
-              <a:t>27</a:t>
+              <a:t>29</a:t>
             </a:r>
           </a:p>
         </p:txBody>
@@ -16063,7 +16065,7 @@
                   <a:srgbClr val="AAAAAA"/>
                 </a:solidFill>
               </a:rPr>
-              <a:t>28</a:t>
+              <a:t>30</a:t>
             </a:r>
           </a:p>
         </p:txBody>
@@ -16458,7 +16460,7 @@
                   <a:srgbClr val="AAAAAA"/>
                 </a:solidFill>
               </a:rPr>
-              <a:t>29</a:t>
+              <a:t>31</a:t>
             </a:r>
           </a:p>
         </p:txBody>
@@ -17183,6 +17185,1845 @@
                 <a:latin typeface="Calibri"/>
               </a:rPr>
               <a:t>Katiki Ravindra Babu  •  Strategic Technology Advisor, Vriksha.ai</a:t>
+            </a:r>
+          </a:p>
+        </p:txBody>
+      </p:sp>
+    </p:spTree>
+  </p:cSld>
+  <p:clrMapOvr>
+    <a:masterClrMapping/>
+  </p:clrMapOvr>
+</p:sld>
+</file>
+
+<file path=ppt/slides/slide31.xml><?xml version="1.0" encoding="utf-8"?>
+<p:sld xmlns:a="http://schemas.openxmlformats.org/drawingml/2006/main" xmlns:p="http://schemas.openxmlformats.org/presentationml/2006/main" xmlns:r="http://schemas.openxmlformats.org/officeDocument/2006/relationships">
+  <p:cSld>
+    <p:spTree>
+      <p:nvGrpSpPr>
+        <p:cNvPr id="1" name=""/>
+        <p:cNvGrpSpPr/>
+        <p:nvPr/>
+      </p:nvGrpSpPr>
+      <p:grpSpPr/>
+      <p:sp>
+        <p:nvSpPr>
+          <p:cNvPr id="2" name="Rectangle 1"/>
+          <p:cNvSpPr/>
+          <p:nvPr/>
+        </p:nvSpPr>
+        <p:spPr>
+          <a:xfrm>
+            <a:off x="0" y="0"/>
+            <a:ext cx="12192000" cy="6858000"/>
+          </a:xfrm>
+          <a:prstGeom prst="rect">
+            <a:avLst/>
+          </a:prstGeom>
+          <a:solidFill>
+            <a:srgbClr val="171115"/>
+          </a:solidFill>
+          <a:ln>
+            <a:noFill/>
+          </a:ln>
+        </p:spPr>
+        <p:style>
+          <a:lnRef idx="1">
+            <a:schemeClr val="accent1"/>
+          </a:lnRef>
+          <a:fillRef idx="3">
+            <a:schemeClr val="accent1"/>
+          </a:fillRef>
+          <a:effectRef idx="2">
+            <a:schemeClr val="accent1"/>
+          </a:effectRef>
+          <a:fontRef idx="minor">
+            <a:schemeClr val="lt1"/>
+          </a:fontRef>
+        </p:style>
+        <p:txBody>
+          <a:bodyPr rtlCol="0" anchor="ctr"/>
+          <a:lstStyle/>
+          <a:p>
+            <a:pPr algn="ctr"/>
+          </a:p>
+        </p:txBody>
+      </p:sp>
+      <p:sp>
+        <p:nvSpPr>
+          <p:cNvPr id="3" name="TextBox 2"/>
+          <p:cNvSpPr txBox="1"/>
+          <p:nvPr/>
+        </p:nvSpPr>
+        <p:spPr>
+          <a:xfrm>
+            <a:off x="457200" y="320040"/>
+            <a:ext cx="11430000" cy="777240"/>
+          </a:xfrm>
+          <a:prstGeom prst="rect">
+            <a:avLst/>
+          </a:prstGeom>
+          <a:noFill/>
+        </p:spPr>
+        <p:txBody>
+          <a:bodyPr wrap="square">
+            <a:spAutoFit/>
+          </a:bodyPr>
+          <a:lstStyle/>
+          <a:p>
+            <a:pPr algn="l"/>
+            <a:r>
+              <a:rPr sz="3000" b="1">
+                <a:solidFill>
+                  <a:srgbClr val="FFFFFF"/>
+                </a:solidFill>
+                <a:latin typeface="Calibri"/>
+              </a:rPr>
+              <a:t>When to Use What — Decision Guide</a:t>
+            </a:r>
+          </a:p>
+        </p:txBody>
+      </p:sp>
+      <p:sp>
+        <p:nvSpPr>
+          <p:cNvPr id="4" name="Rectangle 3"/>
+          <p:cNvSpPr/>
+          <p:nvPr/>
+        </p:nvSpPr>
+        <p:spPr>
+          <a:xfrm>
+            <a:off x="457200" y="1051560"/>
+            <a:ext cx="1188720" cy="64008"/>
+          </a:xfrm>
+          <a:prstGeom prst="rect">
+            <a:avLst/>
+          </a:prstGeom>
+          <a:solidFill>
+            <a:srgbClr val="F46E32"/>
+          </a:solidFill>
+          <a:ln>
+            <a:noFill/>
+          </a:ln>
+        </p:spPr>
+        <p:style>
+          <a:lnRef idx="1">
+            <a:schemeClr val="accent1"/>
+          </a:lnRef>
+          <a:fillRef idx="3">
+            <a:schemeClr val="accent1"/>
+          </a:fillRef>
+          <a:effectRef idx="2">
+            <a:schemeClr val="accent1"/>
+          </a:effectRef>
+          <a:fontRef idx="minor">
+            <a:schemeClr val="lt1"/>
+          </a:fontRef>
+        </p:style>
+        <p:txBody>
+          <a:bodyPr rtlCol="0" anchor="ctr"/>
+          <a:lstStyle/>
+          <a:p>
+            <a:pPr algn="ctr"/>
+          </a:p>
+        </p:txBody>
+      </p:sp>
+      <p:sp>
+        <p:nvSpPr>
+          <p:cNvPr id="5" name="TextBox 4"/>
+          <p:cNvSpPr txBox="1"/>
+          <p:nvPr/>
+        </p:nvSpPr>
+        <p:spPr>
+          <a:xfrm>
+            <a:off x="457200" y="1188720"/>
+            <a:ext cx="11430000" cy="365760"/>
+          </a:xfrm>
+          <a:prstGeom prst="rect">
+            <a:avLst/>
+          </a:prstGeom>
+          <a:noFill/>
+        </p:spPr>
+        <p:txBody>
+          <a:bodyPr wrap="square">
+            <a:spAutoFit/>
+          </a:bodyPr>
+          <a:lstStyle/>
+          <a:p>
+            <a:pPr algn="l"/>
+            <a:r>
+              <a:rPr sz="1400" b="0">
+                <a:solidFill>
+                  <a:srgbClr val="AAAAAA"/>
+                </a:solidFill>
+                <a:latin typeface="Calibri"/>
+              </a:rPr>
+              <a:t>Different query types deserve different retrieval stacks.</a:t>
+            </a:r>
+          </a:p>
+        </p:txBody>
+      </p:sp>
+      <p:sp>
+        <p:nvSpPr>
+          <p:cNvPr id="6" name="Rectangle 5"/>
+          <p:cNvSpPr/>
+          <p:nvPr/>
+        </p:nvSpPr>
+        <p:spPr>
+          <a:xfrm>
+            <a:off x="457200" y="1645920"/>
+            <a:ext cx="4754880" cy="530352"/>
+          </a:xfrm>
+          <a:prstGeom prst="rect">
+            <a:avLst/>
+          </a:prstGeom>
+          <a:solidFill>
+            <a:srgbClr val="F46E32"/>
+          </a:solidFill>
+          <a:ln>
+            <a:solidFill>
+              <a:srgbClr val="F46E32"/>
+            </a:solidFill>
+          </a:ln>
+        </p:spPr>
+        <p:style>
+          <a:lnRef idx="1">
+            <a:schemeClr val="accent1"/>
+          </a:lnRef>
+          <a:fillRef idx="3">
+            <a:schemeClr val="accent1"/>
+          </a:fillRef>
+          <a:effectRef idx="2">
+            <a:schemeClr val="accent1"/>
+          </a:effectRef>
+          <a:fontRef idx="minor">
+            <a:schemeClr val="lt1"/>
+          </a:fontRef>
+        </p:style>
+        <p:txBody>
+          <a:bodyPr rtlCol="0" anchor="ctr"/>
+          <a:lstStyle/>
+          <a:p>
+            <a:pPr algn="ctr"/>
+            <a:r>
+              <a:rPr sz="1400" b="1">
+                <a:solidFill>
+                  <a:srgbClr val="FFFFFF"/>
+                </a:solidFill>
+              </a:rPr>
+              <a:t>Your situation</a:t>
+            </a:r>
+          </a:p>
+        </p:txBody>
+      </p:sp>
+      <p:sp>
+        <p:nvSpPr>
+          <p:cNvPr id="7" name="Rectangle 6"/>
+          <p:cNvSpPr/>
+          <p:nvPr/>
+        </p:nvSpPr>
+        <p:spPr>
+          <a:xfrm>
+            <a:off x="5212080" y="1645920"/>
+            <a:ext cx="3474720" cy="530352"/>
+          </a:xfrm>
+          <a:prstGeom prst="rect">
+            <a:avLst/>
+          </a:prstGeom>
+          <a:solidFill>
+            <a:srgbClr val="F46E32"/>
+          </a:solidFill>
+          <a:ln>
+            <a:solidFill>
+              <a:srgbClr val="F46E32"/>
+            </a:solidFill>
+          </a:ln>
+        </p:spPr>
+        <p:style>
+          <a:lnRef idx="1">
+            <a:schemeClr val="accent1"/>
+          </a:lnRef>
+          <a:fillRef idx="3">
+            <a:schemeClr val="accent1"/>
+          </a:fillRef>
+          <a:effectRef idx="2">
+            <a:schemeClr val="accent1"/>
+          </a:effectRef>
+          <a:fontRef idx="minor">
+            <a:schemeClr val="lt1"/>
+          </a:fontRef>
+        </p:style>
+        <p:txBody>
+          <a:bodyPr rtlCol="0" anchor="ctr"/>
+          <a:lstStyle/>
+          <a:p>
+            <a:pPr algn="ctr"/>
+            <a:r>
+              <a:rPr sz="1400" b="1">
+                <a:solidFill>
+                  <a:srgbClr val="FFFFFF"/>
+                </a:solidFill>
+              </a:rPr>
+              <a:t>Best stack</a:t>
+            </a:r>
+          </a:p>
+        </p:txBody>
+      </p:sp>
+      <p:sp>
+        <p:nvSpPr>
+          <p:cNvPr id="8" name="Rectangle 7"/>
+          <p:cNvSpPr/>
+          <p:nvPr/>
+        </p:nvSpPr>
+        <p:spPr>
+          <a:xfrm>
+            <a:off x="8686800" y="1645920"/>
+            <a:ext cx="3200400" cy="530352"/>
+          </a:xfrm>
+          <a:prstGeom prst="rect">
+            <a:avLst/>
+          </a:prstGeom>
+          <a:solidFill>
+            <a:srgbClr val="F46E32"/>
+          </a:solidFill>
+          <a:ln>
+            <a:solidFill>
+              <a:srgbClr val="F46E32"/>
+            </a:solidFill>
+          </a:ln>
+        </p:spPr>
+        <p:style>
+          <a:lnRef idx="1">
+            <a:schemeClr val="accent1"/>
+          </a:lnRef>
+          <a:fillRef idx="3">
+            <a:schemeClr val="accent1"/>
+          </a:fillRef>
+          <a:effectRef idx="2">
+            <a:schemeClr val="accent1"/>
+          </a:effectRef>
+          <a:fontRef idx="minor">
+            <a:schemeClr val="lt1"/>
+          </a:fontRef>
+        </p:style>
+        <p:txBody>
+          <a:bodyPr rtlCol="0" anchor="ctr"/>
+          <a:lstStyle/>
+          <a:p>
+            <a:pPr algn="ctr"/>
+            <a:r>
+              <a:rPr sz="1400" b="1">
+                <a:solidFill>
+                  <a:srgbClr val="FFFFFF"/>
+                </a:solidFill>
+              </a:rPr>
+              <a:t>Why</a:t>
+            </a:r>
+          </a:p>
+        </p:txBody>
+      </p:sp>
+      <p:sp>
+        <p:nvSpPr>
+          <p:cNvPr id="9" name="Rectangle 8"/>
+          <p:cNvSpPr/>
+          <p:nvPr/>
+        </p:nvSpPr>
+        <p:spPr>
+          <a:xfrm>
+            <a:off x="457200" y="2176272"/>
+            <a:ext cx="4754880" cy="530352"/>
+          </a:xfrm>
+          <a:prstGeom prst="rect">
+            <a:avLst/>
+          </a:prstGeom>
+          <a:solidFill>
+            <a:srgbClr val="221B1F"/>
+          </a:solidFill>
+          <a:ln w="6350">
+            <a:solidFill>
+              <a:srgbClr val="F46E32"/>
+            </a:solidFill>
+          </a:ln>
+        </p:spPr>
+        <p:style>
+          <a:lnRef idx="1">
+            <a:schemeClr val="accent1"/>
+          </a:lnRef>
+          <a:fillRef idx="3">
+            <a:schemeClr val="accent1"/>
+          </a:fillRef>
+          <a:effectRef idx="2">
+            <a:schemeClr val="accent1"/>
+          </a:effectRef>
+          <a:fontRef idx="minor">
+            <a:schemeClr val="lt1"/>
+          </a:fontRef>
+        </p:style>
+        <p:txBody>
+          <a:bodyPr rtlCol="0" anchor="ctr"/>
+          <a:lstStyle/>
+          <a:p>
+            <a:pPr algn="ctr"/>
+            <a:r>
+              <a:rPr sz="1300">
+                <a:solidFill>
+                  <a:srgbClr val="FFFFFF"/>
+                </a:solidFill>
+              </a:rPr>
+              <a:t>Small corpus (&lt;1k docs), conceptual questions</a:t>
+            </a:r>
+          </a:p>
+        </p:txBody>
+      </p:sp>
+      <p:sp>
+        <p:nvSpPr>
+          <p:cNvPr id="10" name="Rectangle 9"/>
+          <p:cNvSpPr/>
+          <p:nvPr/>
+        </p:nvSpPr>
+        <p:spPr>
+          <a:xfrm>
+            <a:off x="5212080" y="2176272"/>
+            <a:ext cx="3474720" cy="530352"/>
+          </a:xfrm>
+          <a:prstGeom prst="rect">
+            <a:avLst/>
+          </a:prstGeom>
+          <a:solidFill>
+            <a:srgbClr val="221B1F"/>
+          </a:solidFill>
+          <a:ln w="6350">
+            <a:solidFill>
+              <a:srgbClr val="F46E32"/>
+            </a:solidFill>
+          </a:ln>
+        </p:spPr>
+        <p:style>
+          <a:lnRef idx="1">
+            <a:schemeClr val="accent1"/>
+          </a:lnRef>
+          <a:fillRef idx="3">
+            <a:schemeClr val="accent1"/>
+          </a:fillRef>
+          <a:effectRef idx="2">
+            <a:schemeClr val="accent1"/>
+          </a:effectRef>
+          <a:fontRef idx="minor">
+            <a:schemeClr val="lt1"/>
+          </a:fontRef>
+        </p:style>
+        <p:txBody>
+          <a:bodyPr rtlCol="0" anchor="ctr"/>
+          <a:lstStyle/>
+          <a:p>
+            <a:pPr algn="ctr"/>
+            <a:r>
+              <a:rPr sz="1300">
+                <a:solidFill>
+                  <a:srgbClr val="FFFFFF"/>
+                </a:solidFill>
+              </a:rPr>
+              <a:t>Dense only</a:t>
+            </a:r>
+          </a:p>
+        </p:txBody>
+      </p:sp>
+      <p:sp>
+        <p:nvSpPr>
+          <p:cNvPr id="11" name="Rectangle 10"/>
+          <p:cNvSpPr/>
+          <p:nvPr/>
+        </p:nvSpPr>
+        <p:spPr>
+          <a:xfrm>
+            <a:off x="8686800" y="2176272"/>
+            <a:ext cx="3200400" cy="530352"/>
+          </a:xfrm>
+          <a:prstGeom prst="rect">
+            <a:avLst/>
+          </a:prstGeom>
+          <a:solidFill>
+            <a:srgbClr val="221B1F"/>
+          </a:solidFill>
+          <a:ln w="6350">
+            <a:solidFill>
+              <a:srgbClr val="F46E32"/>
+            </a:solidFill>
+          </a:ln>
+        </p:spPr>
+        <p:style>
+          <a:lnRef idx="1">
+            <a:schemeClr val="accent1"/>
+          </a:lnRef>
+          <a:fillRef idx="3">
+            <a:schemeClr val="accent1"/>
+          </a:fillRef>
+          <a:effectRef idx="2">
+            <a:schemeClr val="accent1"/>
+          </a:effectRef>
+          <a:fontRef idx="minor">
+            <a:schemeClr val="lt1"/>
+          </a:fontRef>
+        </p:style>
+        <p:txBody>
+          <a:bodyPr rtlCol="0" anchor="ctr"/>
+          <a:lstStyle/>
+          <a:p>
+            <a:pPr algn="ctr"/>
+            <a:r>
+              <a:rPr sz="1300">
+                <a:solidFill>
+                  <a:srgbClr val="FFFFFF"/>
+                </a:solidFill>
+              </a:rPr>
+              <a:t>Simpler, faster, recall is easy</a:t>
+            </a:r>
+          </a:p>
+        </p:txBody>
+      </p:sp>
+      <p:sp>
+        <p:nvSpPr>
+          <p:cNvPr id="12" name="Rectangle 11"/>
+          <p:cNvSpPr/>
+          <p:nvPr/>
+        </p:nvSpPr>
+        <p:spPr>
+          <a:xfrm>
+            <a:off x="457200" y="2706624"/>
+            <a:ext cx="4754880" cy="530352"/>
+          </a:xfrm>
+          <a:prstGeom prst="rect">
+            <a:avLst/>
+          </a:prstGeom>
+          <a:solidFill>
+            <a:srgbClr val="2A2125"/>
+          </a:solidFill>
+          <a:ln w="6350">
+            <a:solidFill>
+              <a:srgbClr val="F46E32"/>
+            </a:solidFill>
+          </a:ln>
+        </p:spPr>
+        <p:style>
+          <a:lnRef idx="1">
+            <a:schemeClr val="accent1"/>
+          </a:lnRef>
+          <a:fillRef idx="3">
+            <a:schemeClr val="accent1"/>
+          </a:fillRef>
+          <a:effectRef idx="2">
+            <a:schemeClr val="accent1"/>
+          </a:effectRef>
+          <a:fontRef idx="minor">
+            <a:schemeClr val="lt1"/>
+          </a:fontRef>
+        </p:style>
+        <p:txBody>
+          <a:bodyPr rtlCol="0" anchor="ctr"/>
+          <a:lstStyle/>
+          <a:p>
+            <a:pPr algn="ctr"/>
+            <a:r>
+              <a:rPr sz="1300">
+                <a:solidFill>
+                  <a:srgbClr val="FFFFFF"/>
+                </a:solidFill>
+              </a:rPr>
+              <a:t>Exact-match queries (IDs, codes, product SKUs)</a:t>
+            </a:r>
+          </a:p>
+        </p:txBody>
+      </p:sp>
+      <p:sp>
+        <p:nvSpPr>
+          <p:cNvPr id="13" name="Rectangle 12"/>
+          <p:cNvSpPr/>
+          <p:nvPr/>
+        </p:nvSpPr>
+        <p:spPr>
+          <a:xfrm>
+            <a:off x="5212080" y="2706624"/>
+            <a:ext cx="3474720" cy="530352"/>
+          </a:xfrm>
+          <a:prstGeom prst="rect">
+            <a:avLst/>
+          </a:prstGeom>
+          <a:solidFill>
+            <a:srgbClr val="2A2125"/>
+          </a:solidFill>
+          <a:ln w="6350">
+            <a:solidFill>
+              <a:srgbClr val="F46E32"/>
+            </a:solidFill>
+          </a:ln>
+        </p:spPr>
+        <p:style>
+          <a:lnRef idx="1">
+            <a:schemeClr val="accent1"/>
+          </a:lnRef>
+          <a:fillRef idx="3">
+            <a:schemeClr val="accent1"/>
+          </a:fillRef>
+          <a:effectRef idx="2">
+            <a:schemeClr val="accent1"/>
+          </a:effectRef>
+          <a:fontRef idx="minor">
+            <a:schemeClr val="lt1"/>
+          </a:fontRef>
+        </p:style>
+        <p:txBody>
+          <a:bodyPr rtlCol="0" anchor="ctr"/>
+          <a:lstStyle/>
+          <a:p>
+            <a:pPr algn="ctr"/>
+            <a:r>
+              <a:rPr sz="1300">
+                <a:solidFill>
+                  <a:srgbClr val="FFFFFF"/>
+                </a:solidFill>
+              </a:rPr>
+              <a:t>BM25 only</a:t>
+            </a:r>
+          </a:p>
+        </p:txBody>
+      </p:sp>
+      <p:sp>
+        <p:nvSpPr>
+          <p:cNvPr id="14" name="Rectangle 13"/>
+          <p:cNvSpPr/>
+          <p:nvPr/>
+        </p:nvSpPr>
+        <p:spPr>
+          <a:xfrm>
+            <a:off x="8686800" y="2706624"/>
+            <a:ext cx="3200400" cy="530352"/>
+          </a:xfrm>
+          <a:prstGeom prst="rect">
+            <a:avLst/>
+          </a:prstGeom>
+          <a:solidFill>
+            <a:srgbClr val="2A2125"/>
+          </a:solidFill>
+          <a:ln w="6350">
+            <a:solidFill>
+              <a:srgbClr val="F46E32"/>
+            </a:solidFill>
+          </a:ln>
+        </p:spPr>
+        <p:style>
+          <a:lnRef idx="1">
+            <a:schemeClr val="accent1"/>
+          </a:lnRef>
+          <a:fillRef idx="3">
+            <a:schemeClr val="accent1"/>
+          </a:fillRef>
+          <a:effectRef idx="2">
+            <a:schemeClr val="accent1"/>
+          </a:effectRef>
+          <a:fontRef idx="minor">
+            <a:schemeClr val="lt1"/>
+          </a:fontRef>
+        </p:style>
+        <p:txBody>
+          <a:bodyPr rtlCol="0" anchor="ctr"/>
+          <a:lstStyle/>
+          <a:p>
+            <a:pPr algn="ctr"/>
+            <a:r>
+              <a:rPr sz="1300">
+                <a:solidFill>
+                  <a:srgbClr val="FFFFFF"/>
+                </a:solidFill>
+              </a:rPr>
+              <a:t>Keyword precision beats semantic blur</a:t>
+            </a:r>
+          </a:p>
+        </p:txBody>
+      </p:sp>
+      <p:sp>
+        <p:nvSpPr>
+          <p:cNvPr id="15" name="Rectangle 14"/>
+          <p:cNvSpPr/>
+          <p:nvPr/>
+        </p:nvSpPr>
+        <p:spPr>
+          <a:xfrm>
+            <a:off x="457200" y="3236976"/>
+            <a:ext cx="4754880" cy="530352"/>
+          </a:xfrm>
+          <a:prstGeom prst="rect">
+            <a:avLst/>
+          </a:prstGeom>
+          <a:solidFill>
+            <a:srgbClr val="221B1F"/>
+          </a:solidFill>
+          <a:ln w="6350">
+            <a:solidFill>
+              <a:srgbClr val="F46E32"/>
+            </a:solidFill>
+          </a:ln>
+        </p:spPr>
+        <p:style>
+          <a:lnRef idx="1">
+            <a:schemeClr val="accent1"/>
+          </a:lnRef>
+          <a:fillRef idx="3">
+            <a:schemeClr val="accent1"/>
+          </a:fillRef>
+          <a:effectRef idx="2">
+            <a:schemeClr val="accent1"/>
+          </a:effectRef>
+          <a:fontRef idx="minor">
+            <a:schemeClr val="lt1"/>
+          </a:fontRef>
+        </p:style>
+        <p:txBody>
+          <a:bodyPr rtlCol="0" anchor="ctr"/>
+          <a:lstStyle/>
+          <a:p>
+            <a:pPr algn="ctr"/>
+            <a:r>
+              <a:rPr sz="1300">
+                <a:solidFill>
+                  <a:srgbClr val="FFFFFF"/>
+                </a:solidFill>
+              </a:rPr>
+              <a:t>Mixed query styles (most real systems)</a:t>
+            </a:r>
+          </a:p>
+        </p:txBody>
+      </p:sp>
+      <p:sp>
+        <p:nvSpPr>
+          <p:cNvPr id="16" name="Rectangle 15"/>
+          <p:cNvSpPr/>
+          <p:nvPr/>
+        </p:nvSpPr>
+        <p:spPr>
+          <a:xfrm>
+            <a:off x="5212080" y="3236976"/>
+            <a:ext cx="3474720" cy="530352"/>
+          </a:xfrm>
+          <a:prstGeom prst="rect">
+            <a:avLst/>
+          </a:prstGeom>
+          <a:solidFill>
+            <a:srgbClr val="221B1F"/>
+          </a:solidFill>
+          <a:ln w="6350">
+            <a:solidFill>
+              <a:srgbClr val="F46E32"/>
+            </a:solidFill>
+          </a:ln>
+        </p:spPr>
+        <p:style>
+          <a:lnRef idx="1">
+            <a:schemeClr val="accent1"/>
+          </a:lnRef>
+          <a:fillRef idx="3">
+            <a:schemeClr val="accent1"/>
+          </a:fillRef>
+          <a:effectRef idx="2">
+            <a:schemeClr val="accent1"/>
+          </a:effectRef>
+          <a:fontRef idx="minor">
+            <a:schemeClr val="lt1"/>
+          </a:fontRef>
+        </p:style>
+        <p:txBody>
+          <a:bodyPr rtlCol="0" anchor="ctr"/>
+          <a:lstStyle/>
+          <a:p>
+            <a:pPr algn="ctr"/>
+            <a:r>
+              <a:rPr sz="1300">
+                <a:solidFill>
+                  <a:srgbClr val="FFFFFF"/>
+                </a:solidFill>
+              </a:rPr>
+              <a:t>Hybrid (Dense + BM25 + RRF)</a:t>
+            </a:r>
+          </a:p>
+        </p:txBody>
+      </p:sp>
+      <p:sp>
+        <p:nvSpPr>
+          <p:cNvPr id="17" name="Rectangle 16"/>
+          <p:cNvSpPr/>
+          <p:nvPr/>
+        </p:nvSpPr>
+        <p:spPr>
+          <a:xfrm>
+            <a:off x="8686800" y="3236976"/>
+            <a:ext cx="3200400" cy="530352"/>
+          </a:xfrm>
+          <a:prstGeom prst="rect">
+            <a:avLst/>
+          </a:prstGeom>
+          <a:solidFill>
+            <a:srgbClr val="221B1F"/>
+          </a:solidFill>
+          <a:ln w="6350">
+            <a:solidFill>
+              <a:srgbClr val="F46E32"/>
+            </a:solidFill>
+          </a:ln>
+        </p:spPr>
+        <p:style>
+          <a:lnRef idx="1">
+            <a:schemeClr val="accent1"/>
+          </a:lnRef>
+          <a:fillRef idx="3">
+            <a:schemeClr val="accent1"/>
+          </a:fillRef>
+          <a:effectRef idx="2">
+            <a:schemeClr val="accent1"/>
+          </a:effectRef>
+          <a:fontRef idx="minor">
+            <a:schemeClr val="lt1"/>
+          </a:fontRef>
+        </p:style>
+        <p:txBody>
+          <a:bodyPr rtlCol="0" anchor="ctr"/>
+          <a:lstStyle/>
+          <a:p>
+            <a:pPr algn="ctr"/>
+            <a:r>
+              <a:rPr sz="1300">
+                <a:solidFill>
+                  <a:srgbClr val="FFFFFF"/>
+                </a:solidFill>
+              </a:rPr>
+              <a:t>Robust across paraphrases and exact terms</a:t>
+            </a:r>
+          </a:p>
+        </p:txBody>
+      </p:sp>
+      <p:sp>
+        <p:nvSpPr>
+          <p:cNvPr id="18" name="Rectangle 17"/>
+          <p:cNvSpPr/>
+          <p:nvPr/>
+        </p:nvSpPr>
+        <p:spPr>
+          <a:xfrm>
+            <a:off x="457200" y="3767328"/>
+            <a:ext cx="4754880" cy="530352"/>
+          </a:xfrm>
+          <a:prstGeom prst="rect">
+            <a:avLst/>
+          </a:prstGeom>
+          <a:solidFill>
+            <a:srgbClr val="2A2125"/>
+          </a:solidFill>
+          <a:ln w="6350">
+            <a:solidFill>
+              <a:srgbClr val="F46E32"/>
+            </a:solidFill>
+          </a:ln>
+        </p:spPr>
+        <p:style>
+          <a:lnRef idx="1">
+            <a:schemeClr val="accent1"/>
+          </a:lnRef>
+          <a:fillRef idx="3">
+            <a:schemeClr val="accent1"/>
+          </a:fillRef>
+          <a:effectRef idx="2">
+            <a:schemeClr val="accent1"/>
+          </a:effectRef>
+          <a:fontRef idx="minor">
+            <a:schemeClr val="lt1"/>
+          </a:fontRef>
+        </p:style>
+        <p:txBody>
+          <a:bodyPr rtlCol="0" anchor="ctr"/>
+          <a:lstStyle/>
+          <a:p>
+            <a:pPr algn="ctr"/>
+            <a:r>
+              <a:rPr sz="1300">
+                <a:solidFill>
+                  <a:srgbClr val="FFFFFF"/>
+                </a:solidFill>
+              </a:rPr>
+              <a:t>Quality matters more than latency</a:t>
+            </a:r>
+          </a:p>
+        </p:txBody>
+      </p:sp>
+      <p:sp>
+        <p:nvSpPr>
+          <p:cNvPr id="19" name="Rectangle 18"/>
+          <p:cNvSpPr/>
+          <p:nvPr/>
+        </p:nvSpPr>
+        <p:spPr>
+          <a:xfrm>
+            <a:off x="5212080" y="3767328"/>
+            <a:ext cx="3474720" cy="530352"/>
+          </a:xfrm>
+          <a:prstGeom prst="rect">
+            <a:avLst/>
+          </a:prstGeom>
+          <a:solidFill>
+            <a:srgbClr val="2A2125"/>
+          </a:solidFill>
+          <a:ln w="6350">
+            <a:solidFill>
+              <a:srgbClr val="F46E32"/>
+            </a:solidFill>
+          </a:ln>
+        </p:spPr>
+        <p:style>
+          <a:lnRef idx="1">
+            <a:schemeClr val="accent1"/>
+          </a:lnRef>
+          <a:fillRef idx="3">
+            <a:schemeClr val="accent1"/>
+          </a:fillRef>
+          <a:effectRef idx="2">
+            <a:schemeClr val="accent1"/>
+          </a:effectRef>
+          <a:fontRef idx="minor">
+            <a:schemeClr val="lt1"/>
+          </a:fontRef>
+        </p:style>
+        <p:txBody>
+          <a:bodyPr rtlCol="0" anchor="ctr"/>
+          <a:lstStyle/>
+          <a:p>
+            <a:pPr algn="ctr"/>
+            <a:r>
+              <a:rPr sz="1300">
+                <a:solidFill>
+                  <a:srgbClr val="FFFFFF"/>
+                </a:solidFill>
+              </a:rPr>
+              <a:t>Hybrid + Cross-Encoder Re-Ranker</a:t>
+            </a:r>
+          </a:p>
+        </p:txBody>
+      </p:sp>
+      <p:sp>
+        <p:nvSpPr>
+          <p:cNvPr id="20" name="Rectangle 19"/>
+          <p:cNvSpPr/>
+          <p:nvPr/>
+        </p:nvSpPr>
+        <p:spPr>
+          <a:xfrm>
+            <a:off x="8686800" y="3767328"/>
+            <a:ext cx="3200400" cy="530352"/>
+          </a:xfrm>
+          <a:prstGeom prst="rect">
+            <a:avLst/>
+          </a:prstGeom>
+          <a:solidFill>
+            <a:srgbClr val="2A2125"/>
+          </a:solidFill>
+          <a:ln w="6350">
+            <a:solidFill>
+              <a:srgbClr val="F46E32"/>
+            </a:solidFill>
+          </a:ln>
+        </p:spPr>
+        <p:style>
+          <a:lnRef idx="1">
+            <a:schemeClr val="accent1"/>
+          </a:lnRef>
+          <a:fillRef idx="3">
+            <a:schemeClr val="accent1"/>
+          </a:fillRef>
+          <a:effectRef idx="2">
+            <a:schemeClr val="accent1"/>
+          </a:effectRef>
+          <a:fontRef idx="minor">
+            <a:schemeClr val="lt1"/>
+          </a:fontRef>
+        </p:style>
+        <p:txBody>
+          <a:bodyPr rtlCol="0" anchor="ctr"/>
+          <a:lstStyle/>
+          <a:p>
+            <a:pPr algn="ctr"/>
+            <a:r>
+              <a:rPr sz="1300">
+                <a:solidFill>
+                  <a:srgbClr val="FFFFFF"/>
+                </a:solidFill>
+              </a:rPr>
+              <a:t>Highest precision per millisecond</a:t>
+            </a:r>
+          </a:p>
+        </p:txBody>
+      </p:sp>
+      <p:sp>
+        <p:nvSpPr>
+          <p:cNvPr id="21" name="Rectangle 20"/>
+          <p:cNvSpPr/>
+          <p:nvPr/>
+        </p:nvSpPr>
+        <p:spPr>
+          <a:xfrm>
+            <a:off x="457200" y="4297680"/>
+            <a:ext cx="4754880" cy="530352"/>
+          </a:xfrm>
+          <a:prstGeom prst="rect">
+            <a:avLst/>
+          </a:prstGeom>
+          <a:solidFill>
+            <a:srgbClr val="221B1F"/>
+          </a:solidFill>
+          <a:ln w="6350">
+            <a:solidFill>
+              <a:srgbClr val="F46E32"/>
+            </a:solidFill>
+          </a:ln>
+        </p:spPr>
+        <p:style>
+          <a:lnRef idx="1">
+            <a:schemeClr val="accent1"/>
+          </a:lnRef>
+          <a:fillRef idx="3">
+            <a:schemeClr val="accent1"/>
+          </a:fillRef>
+          <a:effectRef idx="2">
+            <a:schemeClr val="accent1"/>
+          </a:effectRef>
+          <a:fontRef idx="minor">
+            <a:schemeClr val="lt1"/>
+          </a:fontRef>
+        </p:style>
+        <p:txBody>
+          <a:bodyPr rtlCol="0" anchor="ctr"/>
+          <a:lstStyle/>
+          <a:p>
+            <a:pPr algn="ctr"/>
+            <a:r>
+              <a:rPr sz="1300">
+                <a:solidFill>
+                  <a:srgbClr val="FFFFFF"/>
+                </a:solidFill>
+              </a:rPr>
+              <a:t>Highly structured data (relational records)</a:t>
+            </a:r>
+          </a:p>
+        </p:txBody>
+      </p:sp>
+      <p:sp>
+        <p:nvSpPr>
+          <p:cNvPr id="22" name="Rectangle 21"/>
+          <p:cNvSpPr/>
+          <p:nvPr/>
+        </p:nvSpPr>
+        <p:spPr>
+          <a:xfrm>
+            <a:off x="5212080" y="4297680"/>
+            <a:ext cx="3474720" cy="530352"/>
+          </a:xfrm>
+          <a:prstGeom prst="rect">
+            <a:avLst/>
+          </a:prstGeom>
+          <a:solidFill>
+            <a:srgbClr val="221B1F"/>
+          </a:solidFill>
+          <a:ln w="6350">
+            <a:solidFill>
+              <a:srgbClr val="F46E32"/>
+            </a:solidFill>
+          </a:ln>
+        </p:spPr>
+        <p:style>
+          <a:lnRef idx="1">
+            <a:schemeClr val="accent1"/>
+          </a:lnRef>
+          <a:fillRef idx="3">
+            <a:schemeClr val="accent1"/>
+          </a:fillRef>
+          <a:effectRef idx="2">
+            <a:schemeClr val="accent1"/>
+          </a:effectRef>
+          <a:fontRef idx="minor">
+            <a:schemeClr val="lt1"/>
+          </a:fontRef>
+        </p:style>
+        <p:txBody>
+          <a:bodyPr rtlCol="0" anchor="ctr"/>
+          <a:lstStyle/>
+          <a:p>
+            <a:pPr algn="ctr"/>
+            <a:r>
+              <a:rPr sz="1300">
+                <a:solidFill>
+                  <a:srgbClr val="FFFFFF"/>
+                </a:solidFill>
+              </a:rPr>
+              <a:t>SQL / SPARQL, not RAG</a:t>
+            </a:r>
+          </a:p>
+        </p:txBody>
+      </p:sp>
+      <p:sp>
+        <p:nvSpPr>
+          <p:cNvPr id="23" name="Rectangle 22"/>
+          <p:cNvSpPr/>
+          <p:nvPr/>
+        </p:nvSpPr>
+        <p:spPr>
+          <a:xfrm>
+            <a:off x="8686800" y="4297680"/>
+            <a:ext cx="3200400" cy="530352"/>
+          </a:xfrm>
+          <a:prstGeom prst="rect">
+            <a:avLst/>
+          </a:prstGeom>
+          <a:solidFill>
+            <a:srgbClr val="221B1F"/>
+          </a:solidFill>
+          <a:ln w="6350">
+            <a:solidFill>
+              <a:srgbClr val="F46E32"/>
+            </a:solidFill>
+          </a:ln>
+        </p:spPr>
+        <p:style>
+          <a:lnRef idx="1">
+            <a:schemeClr val="accent1"/>
+          </a:lnRef>
+          <a:fillRef idx="3">
+            <a:schemeClr val="accent1"/>
+          </a:fillRef>
+          <a:effectRef idx="2">
+            <a:schemeClr val="accent1"/>
+          </a:effectRef>
+          <a:fontRef idx="minor">
+            <a:schemeClr val="lt1"/>
+          </a:fontRef>
+        </p:style>
+        <p:txBody>
+          <a:bodyPr rtlCol="0" anchor="ctr"/>
+          <a:lstStyle/>
+          <a:p>
+            <a:pPr algn="ctr"/>
+            <a:r>
+              <a:rPr sz="1300">
+                <a:solidFill>
+                  <a:srgbClr val="FFFFFF"/>
+                </a:solidFill>
+              </a:rPr>
+              <a:t>Structured query beats vector search</a:t>
+            </a:r>
+          </a:p>
+        </p:txBody>
+      </p:sp>
+      <p:sp>
+        <p:nvSpPr>
+          <p:cNvPr id="24" name="Rectangle 23"/>
+          <p:cNvSpPr/>
+          <p:nvPr/>
+        </p:nvSpPr>
+        <p:spPr>
+          <a:xfrm>
+            <a:off x="457200" y="4828032"/>
+            <a:ext cx="4754880" cy="530352"/>
+          </a:xfrm>
+          <a:prstGeom prst="rect">
+            <a:avLst/>
+          </a:prstGeom>
+          <a:solidFill>
+            <a:srgbClr val="2A2125"/>
+          </a:solidFill>
+          <a:ln w="6350">
+            <a:solidFill>
+              <a:srgbClr val="F46E32"/>
+            </a:solidFill>
+          </a:ln>
+        </p:spPr>
+        <p:style>
+          <a:lnRef idx="1">
+            <a:schemeClr val="accent1"/>
+          </a:lnRef>
+          <a:fillRef idx="3">
+            <a:schemeClr val="accent1"/>
+          </a:fillRef>
+          <a:effectRef idx="2">
+            <a:schemeClr val="accent1"/>
+          </a:effectRef>
+          <a:fontRef idx="minor">
+            <a:schemeClr val="lt1"/>
+          </a:fontRef>
+        </p:style>
+        <p:txBody>
+          <a:bodyPr rtlCol="0" anchor="ctr"/>
+          <a:lstStyle/>
+          <a:p>
+            <a:pPr algn="ctr"/>
+            <a:r>
+              <a:rPr sz="1300">
+                <a:solidFill>
+                  <a:srgbClr val="FFFFFF"/>
+                </a:solidFill>
+              </a:rPr>
+              <a:t>Sub-100ms p99 latency budget</a:t>
+            </a:r>
+          </a:p>
+        </p:txBody>
+      </p:sp>
+      <p:sp>
+        <p:nvSpPr>
+          <p:cNvPr id="25" name="Rectangle 24"/>
+          <p:cNvSpPr/>
+          <p:nvPr/>
+        </p:nvSpPr>
+        <p:spPr>
+          <a:xfrm>
+            <a:off x="5212080" y="4828032"/>
+            <a:ext cx="3474720" cy="530352"/>
+          </a:xfrm>
+          <a:prstGeom prst="rect">
+            <a:avLst/>
+          </a:prstGeom>
+          <a:solidFill>
+            <a:srgbClr val="2A2125"/>
+          </a:solidFill>
+          <a:ln w="6350">
+            <a:solidFill>
+              <a:srgbClr val="F46E32"/>
+            </a:solidFill>
+          </a:ln>
+        </p:spPr>
+        <p:style>
+          <a:lnRef idx="1">
+            <a:schemeClr val="accent1"/>
+          </a:lnRef>
+          <a:fillRef idx="3">
+            <a:schemeClr val="accent1"/>
+          </a:fillRef>
+          <a:effectRef idx="2">
+            <a:schemeClr val="accent1"/>
+          </a:effectRef>
+          <a:fontRef idx="minor">
+            <a:schemeClr val="lt1"/>
+          </a:fontRef>
+        </p:style>
+        <p:txBody>
+          <a:bodyPr rtlCol="0" anchor="ctr"/>
+          <a:lstStyle/>
+          <a:p>
+            <a:pPr algn="ctr"/>
+            <a:r>
+              <a:rPr sz="1300">
+                <a:solidFill>
+                  <a:srgbClr val="FFFFFF"/>
+                </a:solidFill>
+              </a:rPr>
+              <a:t>Dense only, no reranker</a:t>
+            </a:r>
+          </a:p>
+        </p:txBody>
+      </p:sp>
+      <p:sp>
+        <p:nvSpPr>
+          <p:cNvPr id="26" name="Rectangle 25"/>
+          <p:cNvSpPr/>
+          <p:nvPr/>
+        </p:nvSpPr>
+        <p:spPr>
+          <a:xfrm>
+            <a:off x="8686800" y="4828032"/>
+            <a:ext cx="3200400" cy="530352"/>
+          </a:xfrm>
+          <a:prstGeom prst="rect">
+            <a:avLst/>
+          </a:prstGeom>
+          <a:solidFill>
+            <a:srgbClr val="2A2125"/>
+          </a:solidFill>
+          <a:ln w="6350">
+            <a:solidFill>
+              <a:srgbClr val="F46E32"/>
+            </a:solidFill>
+          </a:ln>
+        </p:spPr>
+        <p:style>
+          <a:lnRef idx="1">
+            <a:schemeClr val="accent1"/>
+          </a:lnRef>
+          <a:fillRef idx="3">
+            <a:schemeClr val="accent1"/>
+          </a:fillRef>
+          <a:effectRef idx="2">
+            <a:schemeClr val="accent1"/>
+          </a:effectRef>
+          <a:fontRef idx="minor">
+            <a:schemeClr val="lt1"/>
+          </a:fontRef>
+        </p:style>
+        <p:txBody>
+          <a:bodyPr rtlCol="0" anchor="ctr"/>
+          <a:lstStyle/>
+          <a:p>
+            <a:pPr algn="ctr"/>
+            <a:r>
+              <a:rPr sz="1300">
+                <a:solidFill>
+                  <a:srgbClr val="FFFFFF"/>
+                </a:solidFill>
+              </a:rPr>
+              <a:t>Reranker adds 300–800ms</a:t>
+            </a:r>
+          </a:p>
+        </p:txBody>
+      </p:sp>
+      <p:sp>
+        <p:nvSpPr>
+          <p:cNvPr id="27" name="TextBox 26"/>
+          <p:cNvSpPr txBox="1"/>
+          <p:nvPr/>
+        </p:nvSpPr>
+        <p:spPr>
+          <a:xfrm>
+            <a:off x="640080" y="5852160"/>
+            <a:ext cx="10972800" cy="457200"/>
+          </a:xfrm>
+          <a:prstGeom prst="rect">
+            <a:avLst/>
+          </a:prstGeom>
+          <a:noFill/>
+        </p:spPr>
+        <p:txBody>
+          <a:bodyPr wrap="square">
+            <a:spAutoFit/>
+          </a:bodyPr>
+          <a:lstStyle/>
+          <a:p>
+            <a:pPr algn="ctr"/>
+            <a:r>
+              <a:rPr sz="1500" b="1">
+                <a:solidFill>
+                  <a:srgbClr val="F46E32"/>
+                </a:solidFill>
+                <a:latin typeface="Calibri"/>
+              </a:rPr>
+              <a:t>Start with hybrid + reranker. Drop pieces only when latency or simplicity forces it.</a:t>
+            </a:r>
+          </a:p>
+        </p:txBody>
+      </p:sp>
+    </p:spTree>
+  </p:cSld>
+  <p:clrMapOvr>
+    <a:masterClrMapping/>
+  </p:clrMapOvr>
+</p:sld>
+</file>
+
+<file path=ppt/slides/slide32.xml><?xml version="1.0" encoding="utf-8"?>
+<p:sld xmlns:a="http://schemas.openxmlformats.org/drawingml/2006/main" xmlns:p="http://schemas.openxmlformats.org/presentationml/2006/main" xmlns:r="http://schemas.openxmlformats.org/officeDocument/2006/relationships">
+  <p:cSld>
+    <p:spTree>
+      <p:nvGrpSpPr>
+        <p:cNvPr id="1" name=""/>
+        <p:cNvGrpSpPr/>
+        <p:nvPr/>
+      </p:nvGrpSpPr>
+      <p:grpSpPr/>
+      <p:sp>
+        <p:nvSpPr>
+          <p:cNvPr id="2" name="Rectangle 1"/>
+          <p:cNvSpPr/>
+          <p:nvPr/>
+        </p:nvSpPr>
+        <p:spPr>
+          <a:xfrm>
+            <a:off x="0" y="0"/>
+            <a:ext cx="12192000" cy="6858000"/>
+          </a:xfrm>
+          <a:prstGeom prst="rect">
+            <a:avLst/>
+          </a:prstGeom>
+          <a:solidFill>
+            <a:srgbClr val="171115"/>
+          </a:solidFill>
+          <a:ln>
+            <a:noFill/>
+          </a:ln>
+        </p:spPr>
+        <p:style>
+          <a:lnRef idx="1">
+            <a:schemeClr val="accent1"/>
+          </a:lnRef>
+          <a:fillRef idx="3">
+            <a:schemeClr val="accent1"/>
+          </a:fillRef>
+          <a:effectRef idx="2">
+            <a:schemeClr val="accent1"/>
+          </a:effectRef>
+          <a:fontRef idx="minor">
+            <a:schemeClr val="lt1"/>
+          </a:fontRef>
+        </p:style>
+        <p:txBody>
+          <a:bodyPr rtlCol="0" anchor="ctr"/>
+          <a:lstStyle/>
+          <a:p>
+            <a:pPr algn="ctr"/>
+          </a:p>
+        </p:txBody>
+      </p:sp>
+      <p:sp>
+        <p:nvSpPr>
+          <p:cNvPr id="3" name="TextBox 2"/>
+          <p:cNvSpPr txBox="1"/>
+          <p:nvPr/>
+        </p:nvSpPr>
+        <p:spPr>
+          <a:xfrm>
+            <a:off x="457200" y="320040"/>
+            <a:ext cx="11430000" cy="777240"/>
+          </a:xfrm>
+          <a:prstGeom prst="rect">
+            <a:avLst/>
+          </a:prstGeom>
+          <a:noFill/>
+        </p:spPr>
+        <p:txBody>
+          <a:bodyPr wrap="square">
+            <a:spAutoFit/>
+          </a:bodyPr>
+          <a:lstStyle/>
+          <a:p>
+            <a:pPr algn="l"/>
+            <a:r>
+              <a:rPr sz="3000" b="1">
+                <a:solidFill>
+                  <a:srgbClr val="FFFFFF"/>
+                </a:solidFill>
+                <a:latin typeface="Calibri"/>
+              </a:rPr>
+              <a:t>A Real-World Lesson — When Dense Alone Fails</a:t>
+            </a:r>
+          </a:p>
+        </p:txBody>
+      </p:sp>
+      <p:sp>
+        <p:nvSpPr>
+          <p:cNvPr id="4" name="Rectangle 3"/>
+          <p:cNvSpPr/>
+          <p:nvPr/>
+        </p:nvSpPr>
+        <p:spPr>
+          <a:xfrm>
+            <a:off x="457200" y="1051560"/>
+            <a:ext cx="1188720" cy="64008"/>
+          </a:xfrm>
+          <a:prstGeom prst="rect">
+            <a:avLst/>
+          </a:prstGeom>
+          <a:solidFill>
+            <a:srgbClr val="F46E32"/>
+          </a:solidFill>
+          <a:ln>
+            <a:noFill/>
+          </a:ln>
+        </p:spPr>
+        <p:style>
+          <a:lnRef idx="1">
+            <a:schemeClr val="accent1"/>
+          </a:lnRef>
+          <a:fillRef idx="3">
+            <a:schemeClr val="accent1"/>
+          </a:fillRef>
+          <a:effectRef idx="2">
+            <a:schemeClr val="accent1"/>
+          </a:effectRef>
+          <a:fontRef idx="minor">
+            <a:schemeClr val="lt1"/>
+          </a:fontRef>
+        </p:style>
+        <p:txBody>
+          <a:bodyPr rtlCol="0" anchor="ctr"/>
+          <a:lstStyle/>
+          <a:p>
+            <a:pPr algn="ctr"/>
+          </a:p>
+        </p:txBody>
+      </p:sp>
+      <p:sp>
+        <p:nvSpPr>
+          <p:cNvPr id="5" name="Rounded Rectangle 4"/>
+          <p:cNvSpPr/>
+          <p:nvPr/>
+        </p:nvSpPr>
+        <p:spPr>
+          <a:xfrm>
+            <a:off x="640080" y="1280160"/>
+            <a:ext cx="10972800" cy="1234440"/>
+          </a:xfrm>
+          <a:prstGeom prst="roundRect">
+            <a:avLst/>
+          </a:prstGeom>
+          <a:solidFill>
+            <a:srgbClr val="221B1F"/>
+          </a:solidFill>
+          <a:ln w="15875">
+            <a:solidFill>
+              <a:srgbClr val="F46E32"/>
+            </a:solidFill>
+          </a:ln>
+        </p:spPr>
+        <p:style>
+          <a:lnRef idx="1">
+            <a:schemeClr val="accent1"/>
+          </a:lnRef>
+          <a:fillRef idx="3">
+            <a:schemeClr val="accent1"/>
+          </a:fillRef>
+          <a:effectRef idx="2">
+            <a:schemeClr val="accent1"/>
+          </a:effectRef>
+          <a:fontRef idx="minor">
+            <a:schemeClr val="lt1"/>
+          </a:fontRef>
+        </p:style>
+        <p:txBody>
+          <a:bodyPr rtlCol="0" anchor="ctr" wrap="square" lIns="182880" rIns="182880"/>
+          <a:lstStyle/>
+          <a:p>
+            <a:pPr algn="ctr"/>
+            <a:r>
+              <a:rPr sz="1600" b="1">
+                <a:solidFill>
+                  <a:srgbClr val="F46E32"/>
+                </a:solidFill>
+                <a:latin typeface="Calibri"/>
+              </a:rPr>
+              <a:t>Scenario: </a:t>
+            </a:r>
+            <a:r>
+              <a:rPr sz="1600">
+                <a:solidFill>
+                  <a:srgbClr val="FFFFFF"/>
+                </a:solidFill>
+                <a:latin typeface="Calibri"/>
+              </a:rPr>
+              <a:t>A customer-support team ships a dense-only RAG over their product docs. Three weeks in, users search </a:t>
+            </a:r>
+            <a:r>
+              <a:rPr sz="1600" b="1">
+                <a:solidFill>
+                  <a:srgbClr val="2E8BC4"/>
+                </a:solidFill>
+                <a:latin typeface="Consolas"/>
+              </a:rPr>
+              <a:t>"ORA-04031 fix"</a:t>
+            </a:r>
+            <a:r>
+              <a:rPr sz="1600">
+                <a:solidFill>
+                  <a:srgbClr val="FFFFFF"/>
+                </a:solidFill>
+                <a:latin typeface="Calibri"/>
+              </a:rPr>
+              <a:t> and get an article about Oracle licensing instead of the one that actually debugs the error. Ticket volume climbs; trust tanks.</a:t>
+            </a:r>
+          </a:p>
+        </p:txBody>
+      </p:sp>
+      <p:sp>
+        <p:nvSpPr>
+          <p:cNvPr id="6" name="TextBox 5"/>
+          <p:cNvSpPr txBox="1"/>
+          <p:nvPr/>
+        </p:nvSpPr>
+        <p:spPr>
+          <a:xfrm>
+            <a:off x="640080" y="2743200"/>
+            <a:ext cx="10972800" cy="457200"/>
+          </a:xfrm>
+          <a:prstGeom prst="rect">
+            <a:avLst/>
+          </a:prstGeom>
+          <a:noFill/>
+        </p:spPr>
+        <p:txBody>
+          <a:bodyPr wrap="square">
+            <a:spAutoFit/>
+          </a:bodyPr>
+          <a:lstStyle/>
+          <a:p>
+            <a:pPr algn="l"/>
+            <a:r>
+              <a:rPr sz="1800" b="1">
+                <a:solidFill>
+                  <a:srgbClr val="F46E32"/>
+                </a:solidFill>
+                <a:latin typeface="Calibri"/>
+              </a:rPr>
+              <a:t>What went wrong</a:t>
+            </a:r>
+          </a:p>
+        </p:txBody>
+      </p:sp>
+      <p:sp>
+        <p:nvSpPr>
+          <p:cNvPr id="7" name="TextBox 6"/>
+          <p:cNvSpPr txBox="1"/>
+          <p:nvPr/>
+        </p:nvSpPr>
+        <p:spPr>
+          <a:xfrm>
+            <a:off x="640080" y="3200400"/>
+            <a:ext cx="11247120" cy="2011680"/>
+          </a:xfrm>
+          <a:prstGeom prst="rect">
+            <a:avLst/>
+          </a:prstGeom>
+          <a:noFill/>
+        </p:spPr>
+        <p:txBody>
+          <a:bodyPr wrap="square">
+            <a:spAutoFit/>
+          </a:bodyPr>
+          <a:lstStyle/>
+          <a:p>
+            <a:pPr algn="l">
+              <a:spcAft>
+                <a:spcPts val="700"/>
+              </a:spcAft>
+            </a:pPr>
+            <a:r>
+              <a:rPr sz="1600" b="1">
+                <a:solidFill>
+                  <a:srgbClr val="F46E32"/>
+                </a:solidFill>
+                <a:latin typeface="Calibri"/>
+              </a:rPr>
+              <a:t>▸  </a:t>
+            </a:r>
+            <a:r>
+              <a:rPr b="1" sz="1600">
+                <a:solidFill>
+                  <a:srgbClr val="F46E32"/>
+                </a:solidFill>
+                <a:latin typeface="Calibri"/>
+              </a:rPr>
+              <a:t>Embeddings smooth over exact tokens.</a:t>
+            </a:r>
+            <a:r>
+              <a:rPr sz="1600">
+                <a:solidFill>
+                  <a:srgbClr val="FFFFFF"/>
+                </a:solidFill>
+                <a:latin typeface="Calibri"/>
+              </a:rPr>
+              <a:t> "ORA-04031" is rare; the model finds docs with similar prose, not the exact code.</a:t>
+            </a:r>
+          </a:p>
+          <a:p>
+            <a:pPr algn="l">
+              <a:spcAft>
+                <a:spcPts val="700"/>
+              </a:spcAft>
+            </a:pPr>
+            <a:r>
+              <a:rPr sz="1600" b="1">
+                <a:solidFill>
+                  <a:srgbClr val="F46E32"/>
+                </a:solidFill>
+                <a:latin typeface="Calibri"/>
+              </a:rPr>
+              <a:t>▸  </a:t>
+            </a:r>
+            <a:r>
+              <a:rPr b="1" sz="1600">
+                <a:solidFill>
+                  <a:srgbClr val="F46E32"/>
+                </a:solidFill>
+                <a:latin typeface="Calibri"/>
+              </a:rPr>
+              <a:t>Recall ceiling hit.</a:t>
+            </a:r>
+            <a:r>
+              <a:rPr sz="1600">
+                <a:solidFill>
+                  <a:srgbClr val="FFFFFF"/>
+                </a:solidFill>
+                <a:latin typeface="Calibri"/>
+              </a:rPr>
+              <a:t> The right doc wasn't in the top-50 at all — no amount of prompt tuning could save the generator.</a:t>
+            </a:r>
+          </a:p>
+          <a:p>
+            <a:pPr algn="l">
+              <a:spcAft>
+                <a:spcPts val="700"/>
+              </a:spcAft>
+            </a:pPr>
+            <a:r>
+              <a:rPr sz="1600" b="1">
+                <a:solidFill>
+                  <a:srgbClr val="F46E32"/>
+                </a:solidFill>
+                <a:latin typeface="Calibri"/>
+              </a:rPr>
+              <a:t>▸  </a:t>
+            </a:r>
+            <a:r>
+              <a:rPr b="1" sz="1600">
+                <a:solidFill>
+                  <a:srgbClr val="F46E32"/>
+                </a:solidFill>
+                <a:latin typeface="Calibri"/>
+              </a:rPr>
+              <a:t>The generator looked confident.</a:t>
+            </a:r>
+            <a:r>
+              <a:rPr sz="1600">
+                <a:solidFill>
+                  <a:srgbClr val="FFFFFF"/>
+                </a:solidFill>
+                <a:latin typeface="Calibri"/>
+              </a:rPr>
+              <a:t> The LLM answered from the wrong doc rather than saying "I don't know".</a:t>
+            </a:r>
+          </a:p>
+        </p:txBody>
+      </p:sp>
+      <p:sp>
+        <p:nvSpPr>
+          <p:cNvPr id="8" name="TextBox 7"/>
+          <p:cNvSpPr txBox="1"/>
+          <p:nvPr/>
+        </p:nvSpPr>
+        <p:spPr>
+          <a:xfrm>
+            <a:off x="640080" y="5120640"/>
+            <a:ext cx="10972800" cy="457200"/>
+          </a:xfrm>
+          <a:prstGeom prst="rect">
+            <a:avLst/>
+          </a:prstGeom>
+          <a:noFill/>
+        </p:spPr>
+        <p:txBody>
+          <a:bodyPr wrap="square">
+            <a:spAutoFit/>
+          </a:bodyPr>
+          <a:lstStyle/>
+          <a:p>
+            <a:pPr algn="l"/>
+            <a:r>
+              <a:rPr sz="1800" b="1">
+                <a:solidFill>
+                  <a:srgbClr val="F46E32"/>
+                </a:solidFill>
+                <a:latin typeface="Calibri"/>
+              </a:rPr>
+              <a:t>What fixed it (one afternoon of work)</a:t>
+            </a:r>
+          </a:p>
+        </p:txBody>
+      </p:sp>
+      <p:sp>
+        <p:nvSpPr>
+          <p:cNvPr id="9" name="TextBox 8"/>
+          <p:cNvSpPr txBox="1"/>
+          <p:nvPr/>
+        </p:nvSpPr>
+        <p:spPr>
+          <a:xfrm>
+            <a:off x="640080" y="5577840"/>
+            <a:ext cx="11247120" cy="731520"/>
+          </a:xfrm>
+          <a:prstGeom prst="rect">
+            <a:avLst/>
+          </a:prstGeom>
+          <a:noFill/>
+        </p:spPr>
+        <p:txBody>
+          <a:bodyPr wrap="square">
+            <a:spAutoFit/>
+          </a:bodyPr>
+          <a:lstStyle/>
+          <a:p>
+            <a:pPr algn="l">
+              <a:spcAft>
+                <a:spcPts val="700"/>
+              </a:spcAft>
+            </a:pPr>
+            <a:r>
+              <a:rPr sz="1500" b="1">
+                <a:solidFill>
+                  <a:srgbClr val="F46E32"/>
+                </a:solidFill>
+                <a:latin typeface="Calibri"/>
+              </a:rPr>
+              <a:t>▸  </a:t>
+            </a:r>
+            <a:r>
+              <a:rPr sz="1500">
+                <a:solidFill>
+                  <a:srgbClr val="FFFFFF"/>
+                </a:solidFill>
+                <a:latin typeface="Calibri"/>
+              </a:rPr>
+              <a:t>Added </a:t>
+            </a:r>
+            <a:r>
+              <a:rPr b="1" sz="1500">
+                <a:solidFill>
+                  <a:srgbClr val="F46E32"/>
+                </a:solidFill>
+                <a:latin typeface="Calibri"/>
+              </a:rPr>
+              <a:t>BM25</a:t>
+            </a:r>
+            <a:r>
+              <a:rPr sz="1500">
+                <a:solidFill>
+                  <a:srgbClr val="FFFFFF"/>
+                </a:solidFill>
+                <a:latin typeface="Calibri"/>
+              </a:rPr>
+              <a:t> alongside dense; fused with </a:t>
+            </a:r>
+            <a:r>
+              <a:rPr b="1" sz="1500">
+                <a:solidFill>
+                  <a:srgbClr val="F46E32"/>
+                </a:solidFill>
+                <a:latin typeface="Calibri"/>
+              </a:rPr>
+              <a:t>RRF</a:t>
+            </a:r>
+            <a:r>
+              <a:rPr sz="1500">
+                <a:solidFill>
+                  <a:srgbClr val="FFFFFF"/>
+                </a:solidFill>
+                <a:latin typeface="Calibri"/>
+              </a:rPr>
+              <a:t> — exact-code match jumped to rank 1. Added a </a:t>
+            </a:r>
+            <a:r>
+              <a:rPr b="1" sz="1500">
+                <a:solidFill>
+                  <a:srgbClr val="F46E32"/>
+                </a:solidFill>
+                <a:latin typeface="Calibri"/>
+              </a:rPr>
+              <a:t>cross-encoder reranker</a:t>
+            </a:r>
+            <a:r>
+              <a:rPr sz="1500">
+                <a:solidFill>
+                  <a:srgbClr val="FFFFFF"/>
+                </a:solidFill>
+                <a:latin typeface="Calibri"/>
+              </a:rPr>
+              <a:t> to keep noisy matches out of the prompt. Ticket deflection went back above baseline.</a:t>
             </a:r>
           </a:p>
         </p:txBody>

</xml_diff>